<commit_message>
Add Vingroup Korean bond benchmark to memo and slides
Co-Authored-By: Claude Sonnet 5.5 <noreply@anthropic.com>
Claude-Session: https://claude.ai/code/session_01JkmxWL94b2TGL1qFG2y35j
</commit_message>
<xml_diff>
--- a/output/Slides_Sunshine_vs_Vingroup.pptx
+++ b/output/Slides_Sunshine_vs_Vingroup.pptx
@@ -13,6 +13,7 @@
     <p:sldId id="261" r:id="rId12"/>
     <p:sldId id="262" r:id="rId13"/>
     <p:sldId id="263" r:id="rId14"/>
+    <p:sldId id="264" r:id="rId15"/>
   </p:sldIdLst>
   <p:sldSz cx="12188952" cy="6858000" type="screen4x3"/>
   <p:notesSz cx="6858000" cy="9144000"/>
@@ -5197,6 +5198,431 @@
               </a:defRPr>
             </a:pPr>
             <a:r>
+              <a:t>Benchmark: Vingroup's Korean bond</a:t>
+            </a:r>
+          </a:p>
+        </p:txBody>
+      </p:sp>
+      <p:sp>
+        <p:nvSpPr>
+          <p:cNvPr id="4" name="TextBox 3"/>
+          <p:cNvSpPr txBox="1"/>
+          <p:nvPr/>
+        </p:nvSpPr>
+        <p:spPr>
+          <a:xfrm>
+            <a:off x="457200" y="1097280"/>
+            <a:ext cx="11247120" cy="548640"/>
+          </a:xfrm>
+          <a:prstGeom prst="rect">
+            <a:avLst/>
+          </a:prstGeom>
+          <a:noFill/>
+        </p:spPr>
+        <p:txBody>
+          <a:bodyPr wrap="square">
+            <a:spAutoFit/>
+          </a:bodyPr>
+          <a:lstStyle/>
+          <a:p>
+            <a:pPr>
+              <a:spcAft>
+                <a:spcPts val="600"/>
+              </a:spcAft>
+              <a:defRPr sz="1600" b="0">
+                <a:solidFill>
+                  <a:srgbClr val="555555"/>
+                </a:solidFill>
+              </a:defRPr>
+            </a:pPr>
+            <a:r>
+              <a:t>From press reports - verify against the KED article / prospectus</a:t>
+            </a:r>
+          </a:p>
+        </p:txBody>
+      </p:sp>
+      <p:graphicFrame>
+        <p:nvGraphicFramePr>
+          <p:cNvPr id="5" name="Table 4"/>
+          <p:cNvGraphicFramePr>
+            <a:graphicFrameLocks noGrp="1"/>
+          </p:cNvGraphicFramePr>
+          <p:nvPr/>
+        </p:nvGraphicFramePr>
+        <p:xfrm>
+          <a:off x="731520" y="1737360"/>
+          <a:ext cx="10698480" cy="2560320"/>
+        </p:xfrm>
+        <a:graphic>
+          <a:graphicData uri="http://schemas.openxmlformats.org/drawingml/2006/table">
+            <a:tbl>
+              <a:tblPr firstRow="1" bandRow="1">
+                <a:tableStyleId>{5C22544A-7EE6-4342-B048-85BDC9FD1C3A}</a:tableStyleId>
+              </a:tblPr>
+              <a:tblGrid>
+                <a:gridCol w="3108960"/>
+                <a:gridCol w="7589520"/>
+              </a:tblGrid>
+              <a:tr h="365760">
+                <a:tc>
+                  <a:txBody>
+                    <a:bodyPr/>
+                    <a:lstStyle/>
+                    <a:p>
+                      <a:pPr>
+                        <a:defRPr sz="1500" b="1"/>
+                      </a:pPr>
+                      <a:r>
+                        <a:t>Term</a:t>
+                      </a:r>
+                    </a:p>
+                  </a:txBody>
+                  <a:tcPr/>
+                </a:tc>
+                <a:tc>
+                  <a:txBody>
+                    <a:bodyPr/>
+                    <a:lstStyle/>
+                    <a:p>
+                      <a:pPr>
+                        <a:defRPr sz="1500" b="1"/>
+                      </a:pPr>
+                      <a:r>
+                        <a:t>Reported</a:t>
+                      </a:r>
+                    </a:p>
+                  </a:txBody>
+                  <a:tcPr/>
+                </a:tc>
+              </a:tr>
+              <a:tr h="365760">
+                <a:tc>
+                  <a:txBody>
+                    <a:bodyPr/>
+                    <a:lstStyle/>
+                    <a:p>
+                      <a:pPr>
+                        <a:defRPr sz="1500" b="0"/>
+                      </a:pPr>
+                      <a:r>
+                        <a:t>Size</a:t>
+                      </a:r>
+                    </a:p>
+                  </a:txBody>
+                  <a:tcPr/>
+                </a:tc>
+                <a:tc>
+                  <a:txBody>
+                    <a:bodyPr/>
+                    <a:lstStyle/>
+                    <a:p>
+                      <a:pPr>
+                        <a:defRPr sz="1500" b="0"/>
+                      </a:pPr>
+                      <a:r>
+                        <a:t>KRW 300-400bn (one source says 3,000-4,000bn: likely 10x error)</a:t>
+                      </a:r>
+                    </a:p>
+                  </a:txBody>
+                  <a:tcPr/>
+                </a:tc>
+              </a:tr>
+              <a:tr h="365760">
+                <a:tc>
+                  <a:txBody>
+                    <a:bodyPr/>
+                    <a:lstStyle/>
+                    <a:p>
+                      <a:pPr>
+                        <a:defRPr sz="1500" b="0"/>
+                      </a:pPr>
+                      <a:r>
+                        <a:t>Tenor / format</a:t>
+                      </a:r>
+                    </a:p>
+                  </a:txBody>
+                  <a:tcPr/>
+                </a:tc>
+                <a:tc>
+                  <a:txBody>
+                    <a:bodyPr/>
+                    <a:lstStyle/>
+                    <a:p>
+                      <a:pPr>
+                        <a:defRPr sz="1500" b="0"/>
+                      </a:pPr>
+                      <a:r>
+                        <a:t>3 years, private placement to Korean institutions</a:t>
+                      </a:r>
+                    </a:p>
+                  </a:txBody>
+                  <a:tcPr/>
+                </a:tc>
+              </a:tr>
+              <a:tr h="365760">
+                <a:tc>
+                  <a:txBody>
+                    <a:bodyPr/>
+                    <a:lstStyle/>
+                    <a:p>
+                      <a:pPr>
+                        <a:defRPr sz="1500" b="0"/>
+                      </a:pPr>
+                      <a:r>
+                        <a:t>Coupon</a:t>
+                      </a:r>
+                    </a:p>
+                  </a:txBody>
+                  <a:tcPr/>
+                </a:tc>
+                <a:tc>
+                  <a:txBody>
+                    <a:bodyPr/>
+                    <a:lstStyle/>
+                    <a:p>
+                      <a:pPr>
+                        <a:defRPr sz="1500" b="0"/>
+                      </a:pPr>
+                      <a:r>
+                        <a:t>~7% a year</a:t>
+                      </a:r>
+                    </a:p>
+                  </a:txBody>
+                  <a:tcPr/>
+                </a:tc>
+              </a:tr>
+              <a:tr h="365760">
+                <a:tc>
+                  <a:txBody>
+                    <a:bodyPr/>
+                    <a:lstStyle/>
+                    <a:p>
+                      <a:pPr>
+                        <a:defRPr sz="1500" b="0"/>
+                      </a:pPr>
+                      <a:r>
+                        <a:t>Domestic alternative</a:t>
+                      </a:r>
+                    </a:p>
+                  </a:txBody>
+                  <a:tcPr/>
+                </a:tc>
+                <a:tc>
+                  <a:txBody>
+                    <a:bodyPr/>
+                    <a:lstStyle/>
+                    <a:p>
+                      <a:pPr>
+                        <a:defRPr sz="1500" b="0"/>
+                      </a:pPr>
+                      <a:r>
+                        <a:t>above 11% (Vietnam lending rates ~10%)</a:t>
+                      </a:r>
+                    </a:p>
+                  </a:txBody>
+                  <a:tcPr/>
+                </a:tc>
+              </a:tr>
+              <a:tr h="365760">
+                <a:tc>
+                  <a:txBody>
+                    <a:bodyPr/>
+                    <a:lstStyle/>
+                    <a:p>
+                      <a:pPr>
+                        <a:defRPr sz="1500" b="0"/>
+                      </a:pPr>
+                      <a:r>
+                        <a:t>Underwriters</a:t>
+                      </a:r>
+                    </a:p>
+                  </a:txBody>
+                  <a:tcPr/>
+                </a:tc>
+                <a:tc>
+                  <a:txBody>
+                    <a:bodyPr/>
+                    <a:lstStyle/>
+                    <a:p>
+                      <a:pPr>
+                        <a:defRPr sz="1500" b="0"/>
+                      </a:pPr>
+                      <a:r>
+                        <a:t>KB, Kiwoom, Shinhan Securities</a:t>
+                      </a:r>
+                    </a:p>
+                  </a:txBody>
+                  <a:tcPr/>
+                </a:tc>
+              </a:tr>
+              <a:tr h="365760">
+                <a:tc>
+                  <a:txBody>
+                    <a:bodyPr/>
+                    <a:lstStyle/>
+                    <a:p>
+                      <a:pPr>
+                        <a:defRPr sz="1500" b="0"/>
+                      </a:pPr>
+                      <a:r>
+                        <a:t>Security</a:t>
+                      </a:r>
+                    </a:p>
+                  </a:txBody>
+                  <a:tcPr/>
+                </a:tc>
+                <a:tc>
+                  <a:txBody>
+                    <a:bodyPr/>
+                    <a:lstStyle/>
+                    <a:p>
+                      <a:pPr>
+                        <a:defRPr sz="1500" b="0"/>
+                      </a:pPr>
+                      <a:r>
+                        <a:t>Not stated in sources found</a:t>
+                      </a:r>
+                    </a:p>
+                  </a:txBody>
+                  <a:tcPr/>
+                </a:tc>
+              </a:tr>
+            </a:tbl>
+          </a:graphicData>
+        </a:graphic>
+      </p:graphicFrame>
+      <p:sp>
+        <p:nvSpPr>
+          <p:cNvPr id="6" name="TextBox 5"/>
+          <p:cNvSpPr txBox="1"/>
+          <p:nvPr/>
+        </p:nvSpPr>
+        <p:spPr>
+          <a:xfrm>
+            <a:off x="731520" y="4937760"/>
+            <a:ext cx="10698480" cy="1280160"/>
+          </a:xfrm>
+          <a:prstGeom prst="rect">
+            <a:avLst/>
+          </a:prstGeom>
+          <a:noFill/>
+        </p:spPr>
+        <p:txBody>
+          <a:bodyPr wrap="square">
+            <a:spAutoFit/>
+          </a:bodyPr>
+          <a:lstStyle/>
+          <a:p>
+            <a:pPr>
+              <a:spcAft>
+                <a:spcPts val="600"/>
+              </a:spcAft>
+              <a:defRPr sz="1600" b="0">
+                <a:solidFill>
+                  <a:srgbClr val="222222"/>
+                </a:solidFill>
+              </a:defRPr>
+            </a:pPr>
+            <a:r>
+              <a:t>Implication: ~4 points cheaper than domestic funding is the case for Sunshine. As a smaller, newly scaled credit, it should expect a wider spread than 7% unless collateral and covenants compensate.</a:t>
+            </a:r>
+          </a:p>
+        </p:txBody>
+      </p:sp>
+    </p:spTree>
+  </p:cSld>
+  <p:clrMapOvr>
+    <a:masterClrMapping/>
+  </p:clrMapOvr>
+</p:sld>
+</file>
+
+<file path=ppt/slides/slide8.xml><?xml version="1.0" encoding="utf-8"?>
+<p:sld xmlns:a="http://schemas.openxmlformats.org/drawingml/2006/main" xmlns:p="http://schemas.openxmlformats.org/presentationml/2006/main" xmlns:r="http://schemas.openxmlformats.org/officeDocument/2006/relationships">
+  <p:cSld>
+    <p:spTree>
+      <p:nvGrpSpPr>
+        <p:cNvPr id="1" name=""/>
+        <p:cNvGrpSpPr/>
+        <p:nvPr/>
+      </p:nvGrpSpPr>
+      <p:grpSpPr/>
+      <p:sp>
+        <p:nvSpPr>
+          <p:cNvPr id="2" name="Rectangle 1"/>
+          <p:cNvSpPr/>
+          <p:nvPr/>
+        </p:nvSpPr>
+        <p:spPr>
+          <a:xfrm>
+            <a:off x="0" y="0"/>
+            <a:ext cx="12188952" cy="1005840"/>
+          </a:xfrm>
+          <a:prstGeom prst="rect">
+            <a:avLst/>
+          </a:prstGeom>
+          <a:solidFill>
+            <a:srgbClr val="1F3864"/>
+          </a:solidFill>
+          <a:ln>
+            <a:noFill/>
+          </a:ln>
+        </p:spPr>
+        <p:style>
+          <a:lnRef idx="1">
+            <a:schemeClr val="accent1"/>
+          </a:lnRef>
+          <a:fillRef idx="3">
+            <a:schemeClr val="accent1"/>
+          </a:fillRef>
+          <a:effectRef idx="2">
+            <a:schemeClr val="accent1"/>
+          </a:effectRef>
+          <a:fontRef idx="minor">
+            <a:schemeClr val="lt1"/>
+          </a:fontRef>
+        </p:style>
+        <p:txBody>
+          <a:bodyPr rtlCol="0" anchor="ctr"/>
+          <a:lstStyle/>
+          <a:p>
+            <a:pPr algn="ctr"/>
+          </a:p>
+        </p:txBody>
+      </p:sp>
+      <p:sp>
+        <p:nvSpPr>
+          <p:cNvPr id="3" name="TextBox 2"/>
+          <p:cNvSpPr txBox="1"/>
+          <p:nvPr/>
+        </p:nvSpPr>
+        <p:spPr>
+          <a:xfrm>
+            <a:off x="457200" y="182880"/>
+            <a:ext cx="11247120" cy="731520"/>
+          </a:xfrm>
+          <a:prstGeom prst="rect">
+            <a:avLst/>
+          </a:prstGeom>
+          <a:noFill/>
+        </p:spPr>
+        <p:txBody>
+          <a:bodyPr wrap="square">
+            <a:spAutoFit/>
+          </a:bodyPr>
+          <a:lstStyle/>
+          <a:p>
+            <a:pPr>
+              <a:spcAft>
+                <a:spcPts val="600"/>
+              </a:spcAft>
+              <a:defRPr sz="2800" b="1">
+                <a:solidFill>
+                  <a:srgbClr val="FFFFFF"/>
+                </a:solidFill>
+              </a:defRPr>
+            </a:pPr>
+            <a:r>
               <a:t>Collateral: the Ciputra land</a:t>
             </a:r>
           </a:p>
@@ -5564,7 +5990,7 @@
 </p:sld>
 </file>
 
-<file path=ppt/slides/slide8.xml><?xml version="1.0" encoding="utf-8"?>
+<file path=ppt/slides/slide9.xml><?xml version="1.0" encoding="utf-8"?>
 <p:sld xmlns:a="http://schemas.openxmlformats.org/drawingml/2006/main" xmlns:p="http://schemas.openxmlformats.org/presentationml/2006/main" xmlns:r="http://schemas.openxmlformats.org/officeDocument/2006/relationships">
   <p:cSld>
     <p:spTree>

</xml_diff>

<commit_message>
Refine Vingroup Korean bond benchmark with VIFC Insight details
Co-Authored-By: Claude Sonnet 5.5 <noreply@anthropic.com>
Claude-Session: https://claude.ai/code/session_01JkmxWL94b2TGL1qFG2y35j
</commit_message>
<xml_diff>
--- a/output/Slides_Sunshine_vs_Vingroup.pptx
+++ b/output/Slides_Sunshine_vs_Vingroup.pptx
@@ -5320,7 +5320,7 @@
                         <a:defRPr sz="1500" b="0"/>
                       </a:pPr>
                       <a:r>
-                        <a:t>KRW 300-400bn (one source says 3,000-4,000bn: likely 10x error)</a:t>
+                        <a:t>~KRW 400bn (board approval up to 455bn); Gate.com 3,000-4,000bn is a 10x error</a:t>
                       </a:r>
                     </a:p>
                   </a:txBody>
@@ -5352,7 +5352,7 @@
                         <a:defRPr sz="1500" b="0"/>
                       </a:pPr>
                       <a:r>
-                        <a:t>3 years, private placement to Korean institutions</a:t>
+                        <a:t>3 years, private placement; first Vietnamese corporate in Korea</a:t>
                       </a:r>
                     </a:p>
                   </a:txBody>
@@ -5384,7 +5384,7 @@
                         <a:defRPr sz="1500" b="0"/>
                       </a:pPr>
                       <a:r>
-                        <a:t>~7% a year</a:t>
+                        <a:t>~7% (Gate.com only, unconfirmed); VIFC: not disclosed</a:t>
                       </a:r>
                     </a:p>
                   </a:txBody>
@@ -5448,7 +5448,7 @@
                         <a:defRPr sz="1500" b="0"/>
                       </a:pPr>
                       <a:r>
-                        <a:t>KB, Kiwoom, Shinhan Securities</a:t>
+                        <a:t>Shinhan Securities Vietnam, KB, Kiwoom</a:t>
                       </a:r>
                     </a:p>
                   </a:txBody>

</xml_diff>

<commit_message>
Update Vingroup bond benchmark (secured, 8% cap) and set collateral calculator to KRW 400bn
Co-Authored-By: Claude Sonnet 5.5 <noreply@anthropic.com>
Claude-Session: https://claude.ai/code/session_01JkmxWL94b2TGL1qFG2y35j
</commit_message>
<xml_diff>
--- a/output/Slides_Sunshine_vs_Vingroup.pptx
+++ b/output/Slides_Sunshine_vs_Vingroup.pptx
@@ -5084,7 +5084,7 @@
               </a:defRPr>
             </a:pPr>
             <a:r>
-              <a:t>•  Multi-market issuer: 2025 domestic bonds via securities firms, a USD 325m exchangeable bond, and the KRW Arirang deal (~KRW 300bn, Shinhan Securities Vietnam arranger, per press).</a:t>
+              <a:t>•  Multi-market issuer: 2025 domestic bonds via securities firms, a USD 325m exchangeable bond, and the KRW Arirang deal (~KRW 300-400bn, Shinhan Securities Vietnam sole arranger, per press).</a:t>
             </a:r>
           </a:p>
           <a:p>
@@ -5099,7 +5099,7 @@
               </a:defRPr>
             </a:pPr>
             <a:r>
-              <a:t>•  Some 2025 Vingroup bond approvals use company assets as security: confirm whether the Korean bond is truly unsecured.</a:t>
+              <a:t>•  Board resolution (11 Aug 2026) describes the Korean bond as secured, non-convertible, 3 years, coupon capped at 8%; pledged assets not disclosed.</a:t>
             </a:r>
           </a:p>
         </p:txBody>
@@ -5236,7 +5236,7 @@
               </a:defRPr>
             </a:pPr>
             <a:r>
-              <a:t>From press reports - verify against the KED article / prospectus</a:t>
+              <a:t>From press reports and board resolution coverage - verify against the original Vingroup disclosure</a:t>
             </a:r>
           </a:p>
         </p:txBody>
@@ -5320,7 +5320,7 @@
                         <a:defRPr sz="1500" b="0"/>
                       </a:pPr>
                       <a:r>
-                        <a:t>~KRW 400bn (board approval up to 455bn); Gate.com 3,000-4,000bn is a 10x error</a:t>
+                        <a:t>KRW 300-400bn (board approval up to 455bn); ~300bn demand secured</a:t>
                       </a:r>
                     </a:p>
                   </a:txBody>
@@ -5352,7 +5352,7 @@
                         <a:defRPr sz="1500" b="0"/>
                       </a:pPr>
                       <a:r>
-                        <a:t>3 years, private placement; first Vietnamese corporate in Korea</a:t>
+                        <a:t>3 years, private placement, direct Vingroup obligation; first Vietnamese corporate Arirang bond</a:t>
                       </a:r>
                     </a:p>
                   </a:txBody>
@@ -5384,7 +5384,7 @@
                         <a:defRPr sz="1500" b="0"/>
                       </a:pPr>
                       <a:r>
-                        <a:t>~7% (Gate.com only, unconfirmed); VIFC: not disclosed</a:t>
+                        <a:t>Capped at 8%; Korean press expects ~7% (not yet issued)</a:t>
                       </a:r>
                     </a:p>
                   </a:txBody>
@@ -5448,7 +5448,7 @@
                         <a:defRPr sz="1500" b="0"/>
                       </a:pPr>
                       <a:r>
-                        <a:t>Shinhan Securities Vietnam, KB, Kiwoom</a:t>
+                        <a:t>Shinhan Securities Vietnam (sole arranger), KB, Kiwoom; Shinhan invests KRW 40bn</a:t>
                       </a:r>
                     </a:p>
                   </a:txBody>
@@ -5480,7 +5480,7 @@
                         <a:defRPr sz="1500" b="0"/>
                       </a:pPr>
                       <a:r>
-                        <a:t>Not stated in sources found</a:t>
+                        <a:t>Secured per board resolution (4 outlets; 1 says unsecured); assets undisclosed</a:t>
                       </a:r>
                     </a:p>
                   </a:txBody>
@@ -5524,7 +5524,7 @@
               </a:defRPr>
             </a:pPr>
             <a:r>
-              <a:t>Implication: ~4 points cheaper than domestic funding is the case for Sunshine. As a smaller, newly scaled credit, it should expect a wider spread than 7% unless collateral and covenants compensate.</a:t>
+              <a:t>Implication: ~4 points cheaper than domestic funding is the case for Sunshine, and a secured structure is in line with Vingroup. As a smaller, newly scaled credit, Sunshine should expect a wider spread than ~7% unless collateral and covenants compensate.</a:t>
             </a:r>
           </a:p>
         </p:txBody>
@@ -5730,7 +5730,7 @@
                         <a:defRPr sz="1500" b="0"/>
                       </a:pPr>
                       <a:r>
-                        <a:t>Bond (KRW 300bn at 18 VND/KRW)</a:t>
+                        <a:t>Bond (KRW 400bn at 18 VND/KRW)</a:t>
                       </a:r>
                     </a:p>
                   </a:txBody>
@@ -5745,7 +5745,7 @@
                         <a:defRPr sz="1500" b="0"/>
                       </a:pPr>
                       <a:r>
-                        <a:t>VND 5,400bn</a:t>
+                        <a:t>VND 7,200bn</a:t>
                       </a:r>
                     </a:p>
                   </a:txBody>
@@ -5841,7 +5841,7 @@
                         <a:defRPr sz="1500" b="0"/>
                       </a:pPr>
                       <a:r>
-                        <a:t>~VND 12,900bn</a:t>
+                        <a:t>~VND 17,100bn</a:t>
                       </a:r>
                     </a:p>
                   </a:txBody>
@@ -5873,7 +5873,7 @@
                         <a:defRPr sz="1500" b="0"/>
                       </a:pPr>
                       <a:r>
-                        <a:t>LTV 77% - fails target</a:t>
+                        <a:t>LTV 103% - fails target</a:t>
                       </a:r>
                     </a:p>
                   </a:txBody>

</xml_diff>